<commit_message>
update of pptx file
</commit_message>
<xml_diff>
--- a/formation_pptx_test.pptx
+++ b/formation_pptx_test.pptx
@@ -261,7 +261,7 @@
           <a:p>
             <a:fld id="{47912B13-307C-461C-9EF5-D374B43372A3}" type="datetimeFigureOut">
               <a:rPr lang="en-US" smtClean="0"/>
-              <a:t>9/26/2025</a:t>
+              <a:t>9/27/2025</a:t>
             </a:fld>
             <a:endParaRPr lang="en-US"/>
           </a:p>
@@ -461,7 +461,7 @@
           <a:p>
             <a:fld id="{47912B13-307C-461C-9EF5-D374B43372A3}" type="datetimeFigureOut">
               <a:rPr lang="en-US" smtClean="0"/>
-              <a:t>9/26/2025</a:t>
+              <a:t>9/27/2025</a:t>
             </a:fld>
             <a:endParaRPr lang="en-US"/>
           </a:p>
@@ -671,7 +671,7 @@
           <a:p>
             <a:fld id="{47912B13-307C-461C-9EF5-D374B43372A3}" type="datetimeFigureOut">
               <a:rPr lang="en-US" smtClean="0"/>
-              <a:t>9/26/2025</a:t>
+              <a:t>9/27/2025</a:t>
             </a:fld>
             <a:endParaRPr lang="en-US"/>
           </a:p>
@@ -871,7 +871,7 @@
           <a:p>
             <a:fld id="{47912B13-307C-461C-9EF5-D374B43372A3}" type="datetimeFigureOut">
               <a:rPr lang="en-US" smtClean="0"/>
-              <a:t>9/26/2025</a:t>
+              <a:t>9/27/2025</a:t>
             </a:fld>
             <a:endParaRPr lang="en-US"/>
           </a:p>
@@ -1147,7 +1147,7 @@
           <a:p>
             <a:fld id="{47912B13-307C-461C-9EF5-D374B43372A3}" type="datetimeFigureOut">
               <a:rPr lang="en-US" smtClean="0"/>
-              <a:t>9/26/2025</a:t>
+              <a:t>9/27/2025</a:t>
             </a:fld>
             <a:endParaRPr lang="en-US"/>
           </a:p>
@@ -1415,7 +1415,7 @@
           <a:p>
             <a:fld id="{47912B13-307C-461C-9EF5-D374B43372A3}" type="datetimeFigureOut">
               <a:rPr lang="en-US" smtClean="0"/>
-              <a:t>9/26/2025</a:t>
+              <a:t>9/27/2025</a:t>
             </a:fld>
             <a:endParaRPr lang="en-US"/>
           </a:p>
@@ -1830,7 +1830,7 @@
           <a:p>
             <a:fld id="{47912B13-307C-461C-9EF5-D374B43372A3}" type="datetimeFigureOut">
               <a:rPr lang="en-US" smtClean="0"/>
-              <a:t>9/26/2025</a:t>
+              <a:t>9/27/2025</a:t>
             </a:fld>
             <a:endParaRPr lang="en-US"/>
           </a:p>
@@ -1972,7 +1972,7 @@
           <a:p>
             <a:fld id="{47912B13-307C-461C-9EF5-D374B43372A3}" type="datetimeFigureOut">
               <a:rPr lang="en-US" smtClean="0"/>
-              <a:t>9/26/2025</a:t>
+              <a:t>9/27/2025</a:t>
             </a:fld>
             <a:endParaRPr lang="en-US"/>
           </a:p>
@@ -2085,7 +2085,7 @@
           <a:p>
             <a:fld id="{47912B13-307C-461C-9EF5-D374B43372A3}" type="datetimeFigureOut">
               <a:rPr lang="en-US" smtClean="0"/>
-              <a:t>9/26/2025</a:t>
+              <a:t>9/27/2025</a:t>
             </a:fld>
             <a:endParaRPr lang="en-US"/>
           </a:p>
@@ -2398,7 +2398,7 @@
           <a:p>
             <a:fld id="{47912B13-307C-461C-9EF5-D374B43372A3}" type="datetimeFigureOut">
               <a:rPr lang="en-US" smtClean="0"/>
-              <a:t>9/26/2025</a:t>
+              <a:t>9/27/2025</a:t>
             </a:fld>
             <a:endParaRPr lang="en-US"/>
           </a:p>
@@ -2687,7 +2687,7 @@
           <a:p>
             <a:fld id="{47912B13-307C-461C-9EF5-D374B43372A3}" type="datetimeFigureOut">
               <a:rPr lang="en-US" smtClean="0"/>
-              <a:t>9/26/2025</a:t>
+              <a:t>9/27/2025</a:t>
             </a:fld>
             <a:endParaRPr lang="en-US"/>
           </a:p>
@@ -2930,7 +2930,7 @@
           <a:p>
             <a:fld id="{47912B13-307C-461C-9EF5-D374B43372A3}" type="datetimeFigureOut">
               <a:rPr lang="en-US" smtClean="0"/>
-              <a:t>9/26/2025</a:t>
+              <a:t>9/27/2025</a:t>
             </a:fld>
             <a:endParaRPr lang="en-US"/>
           </a:p>
@@ -3397,10 +3397,6 @@
           <a:bodyPr/>
           <a:lstStyle/>
           <a:p>
-            <a:r>
-              <a:rPr lang="fr-FR"/>
-              <a:t>Aaaaaaaabbbbaaaaaaa</a:t>
-            </a:r>
             <a:endParaRPr lang="fr-FR" dirty="0"/>
           </a:p>
           <a:p>

</xml_diff>